<commit_message>
release: publish NXP hardware revision
</commit_message>
<xml_diff>
--- a/Resources/NXP integration HW-FW.pptx
+++ b/Resources/NXP integration HW-FW.pptx
@@ -1151,7 +1151,7 @@
 </file>
 
 <file path=ppt/diagrams/colors1.xml><?xml version="1.0" encoding="utf-8"?>
-<dgm:colorsDef xmlns:dgm="http://schemas.openxmlformats.org/drawingml/2006/diagram" xmlns:a="http://schemas.openxmlformats.org/drawingml/2006/main" uniqueId="urn:microsoft.com/office/officeart/2005/8/colors/colorful5">
+<dgm:colorsDef xmlns:dgm="http://schemas.openxmlformats.org/drawingml/2006/diagram" xmlns:a="http://schemas.openxmlformats.org/drawingml/2006/main" uniqueId="urn:microsoft.com/office/officeart/2005/8/colors/colorful5#2">
   <dgm:title val=""/>
   <dgm:desc val=""/>
   <dgm:catLst>
@@ -1936,7 +1936,7 @@
 <dgm:dataModel xmlns:dgm="http://schemas.openxmlformats.org/drawingml/2006/diagram" xmlns:a="http://schemas.openxmlformats.org/drawingml/2006/main">
   <dgm:ptLst>
     <dgm:pt modelId="{52015023-139E-4DFE-856C-B85D440E24A2}" type="doc">
-      <dgm:prSet loTypeId="urn:microsoft.com/office/officeart/2005/8/layout/hProcess4" loCatId="process" qsTypeId="urn:microsoft.com/office/officeart/2005/8/quickstyle/simple1" qsCatId="simple" csTypeId="urn:microsoft.com/office/officeart/2005/8/colors/colorful5" csCatId="colorful" phldr="1"/>
+      <dgm:prSet loTypeId="urn:microsoft.com/office/officeart/2005/8/layout/hProcess4" loCatId="process" qsTypeId="urn:microsoft.com/office/officeart/2005/8/quickstyle/simple1#2" qsCatId="simple" csTypeId="urn:microsoft.com/office/officeart/2005/8/colors/colorful5#2" csCatId="colorful" phldr="1"/>
       <dgm:spPr/>
       <dgm:t>
         <a:bodyPr/>
@@ -2140,14 +2140,17 @@
             <a:buNone/>
           </a:pPr>
           <a:r>
-            <a:rPr lang="en-US" sz="3200" noProof="0"/>
+            <a:rPr lang="en-US" sz="2800" noProof="0" dirty="0"/>
             <a:t>MCU running </a:t>
           </a:r>
           <a:r>
-            <a:rPr lang="en-US" sz="3200" noProof="0" err="1"/>
+            <a:rPr lang="en-US" sz="2800" noProof="0" dirty="0" err="1"/>
             <a:t>AP_Periph</a:t>
           </a:r>
-          <a:endParaRPr lang="en-US" sz="3200" noProof="0"/>
+          <a:r>
+            <a:rPr lang="en-US" sz="2800" noProof="0" dirty="0"/>
+            <a:t> (STM32 MCU)</a:t>
+          </a:r>
         </a:p>
       </dgm:t>
     </dgm:pt>
@@ -2732,7 +2735,7 @@
         </a:bodyPr>
         <a:lstStyle/>
         <a:p>
-          <a:pPr marL="285750" lvl="1" indent="-285750" algn="ctr" defTabSz="1422400">
+          <a:pPr marL="285750" lvl="1" indent="-285750" algn="ctr" defTabSz="1244600">
             <a:lnSpc>
               <a:spcPct val="90000"/>
             </a:lnSpc>
@@ -2745,14 +2748,17 @@
             <a:buNone/>
           </a:pPr>
           <a:r>
-            <a:rPr lang="en-US" sz="3200" kern="1200" noProof="0"/>
+            <a:rPr lang="en-US" sz="2800" kern="1200" noProof="0" dirty="0"/>
             <a:t>MCU running </a:t>
           </a:r>
           <a:r>
-            <a:rPr lang="en-US" sz="3200" kern="1200" noProof="0" err="1"/>
+            <a:rPr lang="en-US" sz="2800" kern="1200" noProof="0" dirty="0" err="1"/>
             <a:t>AP_Periph</a:t>
           </a:r>
-          <a:endParaRPr lang="en-US" sz="3200" kern="1200" noProof="0"/>
+          <a:r>
+            <a:rPr lang="en-US" sz="2800" kern="1200" noProof="0" dirty="0"/>
+            <a:t> (STM32 MCU)</a:t>
+          </a:r>
         </a:p>
       </dsp:txBody>
       <dsp:txXfrm>
@@ -3590,7 +3596,7 @@
 </file>
 
 <file path=ppt/diagrams/quickStyle1.xml><?xml version="1.0" encoding="utf-8"?>
-<dgm:styleDef xmlns:dgm="http://schemas.openxmlformats.org/drawingml/2006/diagram" xmlns:a="http://schemas.openxmlformats.org/drawingml/2006/main" uniqueId="urn:microsoft.com/office/officeart/2005/8/quickstyle/simple1">
+<dgm:styleDef xmlns:dgm="http://schemas.openxmlformats.org/drawingml/2006/diagram" xmlns:a="http://schemas.openxmlformats.org/drawingml/2006/main" uniqueId="urn:microsoft.com/office/officeart/2005/8/quickstyle/simple1#2">
   <dgm:title val=""/>
   <dgm:desc val=""/>
   <dgm:catLst>
@@ -4706,7 +4712,7 @@
             <a:fld id="{4B14F269-9173-FC49-B988-9E9736139D91}" type="datetime1">
               <a:rPr lang="en-US" smtClean="0"/>
               <a:pPr/>
-              <a:t>7/27/2026</a:t>
+              <a:t>9/23/2026</a:t>
             </a:fld>
             <a:endParaRPr lang="nl-NL"/>
           </a:p>
@@ -4773,7 +4779,7 @@
             <a:fld id="{0D5C2AF6-A276-CD44-BCA8-10BF610B3CDD}" type="slidenum">
               <a:rPr lang="nl-NL" smtClean="0"/>
               <a:pPr/>
-              <a:t>‹#›</a:t>
+              <a:t>‹N°›</a:t>
             </a:fld>
             <a:endParaRPr lang="nl-NL"/>
           </a:p>
@@ -4874,7 +4880,7 @@
             <a:fld id="{01FCC812-23AE-FE4D-9B4A-4AF0E37B75E6}" type="datetime1">
               <a:rPr lang="en-US" smtClean="0"/>
               <a:pPr/>
-              <a:t>7/27/2026</a:t>
+              <a:t>9/23/2026</a:t>
             </a:fld>
             <a:endParaRPr lang="nl-NL"/>
           </a:p>
@@ -5034,7 +5040,7 @@
             <a:fld id="{2C11FDA8-A123-3540-B427-6FB1147E5552}" type="slidenum">
               <a:rPr lang="nl-NL" smtClean="0"/>
               <a:pPr/>
-              <a:t>‹#›</a:t>
+              <a:t>‹N°›</a:t>
             </a:fld>
             <a:endParaRPr lang="nl-NL"/>
           </a:p>
@@ -6971,7 +6977,7 @@
                 </a:solidFill>
               </a:rPr>
               <a:pPr/>
-              <a:t>‹#›</a:t>
+              <a:t>‹N°›</a:t>
             </a:fld>
             <a:endParaRPr lang="nl-NL">
               <a:solidFill>
@@ -7216,7 +7222,7 @@
                 </a:solidFill>
               </a:rPr>
               <a:pPr/>
-              <a:t>‹#›</a:t>
+              <a:t>‹N°›</a:t>
             </a:fld>
             <a:endParaRPr lang="nl-NL">
               <a:solidFill>
@@ -7477,7 +7483,7 @@
                 </a:solidFill>
               </a:rPr>
               <a:pPr/>
-              <a:t>‹#›</a:t>
+              <a:t>‹N°›</a:t>
             </a:fld>
             <a:endParaRPr lang="nl-NL">
               <a:solidFill>
@@ -7681,7 +7687,7 @@
                 </a:solidFill>
               </a:rPr>
               <a:pPr/>
-              <a:t>‹#›</a:t>
+              <a:t>‹N°›</a:t>
             </a:fld>
             <a:endParaRPr lang="nl-NL">
               <a:solidFill>
@@ -7899,7 +7905,7 @@
                 </a:solidFill>
               </a:rPr>
               <a:pPr/>
-              <a:t>‹#›</a:t>
+              <a:t>‹N°›</a:t>
             </a:fld>
             <a:endParaRPr lang="nl-NL">
               <a:solidFill>
@@ -8308,7 +8314,7 @@
                 </a:solidFill>
               </a:rPr>
               <a:pPr/>
-              <a:t>‹#›</a:t>
+              <a:t>‹N°›</a:t>
             </a:fld>
             <a:endParaRPr lang="nl-NL">
               <a:solidFill>
@@ -8785,7 +8791,7 @@
                 </a:solidFill>
               </a:rPr>
               <a:pPr algn="ctr"/>
-              <a:t>27 July 2026</a:t>
+              <a:t>23 September 2026</a:t>
             </a:fld>
             <a:endParaRPr lang="en-US" noProof="0">
               <a:solidFill>
@@ -8958,7 +8964,7 @@
           <p:nvPr/>
         </p:nvPicPr>
         <p:blipFill>
-          <a:blip r:embed="rId3">
+          <a:blip r:embed="rId3" cstate="screen">
             <a:extLst>
               <a:ext uri="{28A0092B-C50C-407E-A947-70E740481C1C}">
                 <a14:useLocalDpi xmlns:a14="http://schemas.microsoft.com/office/drawing/2010/main" val="0"/>
@@ -9150,7 +9156,7 @@
           <p:nvPr/>
         </p:nvPicPr>
         <p:blipFill>
-          <a:blip r:embed="rId4">
+          <a:blip r:embed="rId4" cstate="screen">
             <a:extLst>
               <a:ext uri="{28A0092B-C50C-407E-A947-70E740481C1C}">
                 <a14:useLocalDpi xmlns:a14="http://schemas.microsoft.com/office/drawing/2010/main" val="0"/>
@@ -9215,7 +9221,7 @@
           <p:nvPr/>
         </p:nvPicPr>
         <p:blipFill>
-          <a:blip r:embed="rId6">
+          <a:blip r:embed="rId6" cstate="screen">
             <a:extLst>
               <a:ext uri="{28A0092B-C50C-407E-A947-70E740481C1C}">
                 <a14:useLocalDpi xmlns:a14="http://schemas.microsoft.com/office/drawing/2010/main" val="0"/>
@@ -9518,7 +9524,7 @@
           <p:nvPr/>
         </p:nvPicPr>
         <p:blipFill>
-          <a:blip r:embed="rId3">
+          <a:blip r:embed="rId3" cstate="screen">
             <a:extLst>
               <a:ext uri="{28A0092B-C50C-407E-A947-70E740481C1C}">
                 <a14:useLocalDpi xmlns:a14="http://schemas.microsoft.com/office/drawing/2010/main" val="0"/>
@@ -9961,7 +9967,7 @@
           <p:nvPr>
             <p:extLst>
               <p:ext uri="{D42A27DB-BD31-4B8C-83A1-F6EECF244321}">
-                <p14:modId xmlns:p14="http://schemas.microsoft.com/office/powerpoint/2010/main" val="4272280332"/>
+                <p14:modId xmlns:p14="http://schemas.microsoft.com/office/powerpoint/2010/main" val="3161506987"/>
               </p:ext>
             </p:extLst>
           </p:nvPr>
@@ -10953,26 +10959,12 @@
 </file>
 
 <file path=customXml/item1.xml><?xml version="1.0" encoding="utf-8"?>
-<p:properties xmlns:p="http://schemas.microsoft.com/office/2006/metadata/properties" xmlns:xsi="http://www.w3.org/2001/XMLSchema-instance" xmlns:pc="http://schemas.microsoft.com/office/infopath/2007/PartnerControls">
-  <documentManagement>
-    <TaxCatchAll xmlns="378b2ae5-9bc5-4935-9bfa-112face5173f" xsi:nil="true"/>
-    <lcf76f155ced4ddcb4097134ff3c332f xmlns="514a4c4d-b5b8-4628-9a2d-6541241901c3">
-      <Terms xmlns="http://schemas.microsoft.com/office/infopath/2007/PartnerControls"/>
-    </lcf76f155ced4ddcb4097134ff3c332f>
-    <SharedWithUsers xmlns="378b2ae5-9bc5-4935-9bfa-112face5173f">
-      <UserInfo>
-        <DisplayName>Jan Van Hees</DisplayName>
-        <AccountId>64</AccountId>
-        <AccountType/>
-      </UserInfo>
-      <UserInfo>
-        <DisplayName>Gustavo Lopez</DisplayName>
-        <AccountId>53</AccountId>
-        <AccountType/>
-      </UserInfo>
-    </SharedWithUsers>
-  </documentManagement>
-</p:properties>
+<?mso-contentType ?>
+<FormTemplates xmlns="http://schemas.microsoft.com/sharepoint/v3/contenttype/forms">
+  <Display>DocumentLibraryForm</Display>
+  <Edit>DocumentLibraryForm</Edit>
+  <New>DocumentLibraryForm</New>
+</FormTemplates>
 </file>
 
 <file path=customXml/item2.xml><?xml version="1.0" encoding="utf-8"?>
@@ -11237,30 +11229,32 @@
 </file>
 
 <file path=customXml/item3.xml><?xml version="1.0" encoding="utf-8"?>
-<?mso-contentType ?>
-<FormTemplates xmlns="http://schemas.microsoft.com/sharepoint/v3/contenttype/forms">
-  <Display>DocumentLibraryForm</Display>
-  <Edit>DocumentLibraryForm</Edit>
-  <New>DocumentLibraryForm</New>
-</FormTemplates>
+<p:properties xmlns:p="http://schemas.microsoft.com/office/2006/metadata/properties" xmlns:xsi="http://www.w3.org/2001/XMLSchema-instance" xmlns:pc="http://schemas.microsoft.com/office/infopath/2007/PartnerControls">
+  <documentManagement>
+    <TaxCatchAll xmlns="378b2ae5-9bc5-4935-9bfa-112face5173f" xsi:nil="true"/>
+    <lcf76f155ced4ddcb4097134ff3c332f xmlns="514a4c4d-b5b8-4628-9a2d-6541241901c3">
+      <Terms xmlns="http://schemas.microsoft.com/office/infopath/2007/PartnerControls"/>
+    </lcf76f155ced4ddcb4097134ff3c332f>
+    <SharedWithUsers xmlns="378b2ae5-9bc5-4935-9bfa-112face5173f">
+      <UserInfo>
+        <DisplayName>Jan Van Hees</DisplayName>
+        <AccountId>64</AccountId>
+        <AccountType/>
+      </UserInfo>
+      <UserInfo>
+        <DisplayName>Gustavo Lopez</DisplayName>
+        <AccountId>53</AccountId>
+        <AccountType/>
+      </UserInfo>
+    </SharedWithUsers>
+  </documentManagement>
+</p:properties>
 </file>
 
 <file path=customXml/itemProps1.xml><?xml version="1.0" encoding="utf-8"?>
-<ds:datastoreItem xmlns:ds="http://schemas.openxmlformats.org/officeDocument/2006/customXml" ds:itemID="{62CB873E-EF78-49BB-AF94-4108E3FE1383}">
+<ds:datastoreItem xmlns:ds="http://schemas.openxmlformats.org/officeDocument/2006/customXml" ds:itemID="{9F66B594-86E4-494E-A248-FE71313A2624}">
   <ds:schemaRefs>
-    <ds:schemaRef ds:uri="23f005ac-823f-4cde-90bb-9d4dbd99b823"/>
-    <ds:schemaRef ds:uri="378b2ae5-9bc5-4935-9bfa-112face5173f"/>
-    <ds:schemaRef ds:uri="514a4c4d-b5b8-4628-9a2d-6541241901c3"/>
-    <ds:schemaRef ds:uri="c5f5636d-b4bf-4f68-90fa-9fd2db113c37"/>
-    <ds:schemaRef ds:uri="http://purl.org/dc/dcmitype/"/>
-    <ds:schemaRef ds:uri="http://purl.org/dc/elements/1.1/"/>
-    <ds:schemaRef ds:uri="http://purl.org/dc/terms/"/>
-    <ds:schemaRef ds:uri="http://schemas.microsoft.com/office/2006/documentManagement/types"/>
-    <ds:schemaRef ds:uri="http://schemas.microsoft.com/office/2006/metadata/properties"/>
-    <ds:schemaRef ds:uri="http://schemas.microsoft.com/office/infopath/2007/PartnerControls"/>
-    <ds:schemaRef ds:uri="http://schemas.microsoft.com/sharepoint/v3"/>
-    <ds:schemaRef ds:uri="http://schemas.openxmlformats.org/package/2006/metadata/core-properties"/>
-    <ds:schemaRef ds:uri="http://www.w3.org/XML/1998/namespace"/>
+    <ds:schemaRef ds:uri="http://schemas.microsoft.com/sharepoint/v3/contenttype/forms"/>
   </ds:schemaRefs>
 </ds:datastoreItem>
 </file>
@@ -11285,9 +11279,18 @@
 </file>
 
 <file path=customXml/itemProps3.xml><?xml version="1.0" encoding="utf-8"?>
-<ds:datastoreItem xmlns:ds="http://schemas.openxmlformats.org/officeDocument/2006/customXml" ds:itemID="{9F66B594-86E4-494E-A248-FE71313A2624}">
+<ds:datastoreItem xmlns:ds="http://schemas.openxmlformats.org/officeDocument/2006/customXml" ds:itemID="{62CB873E-EF78-49BB-AF94-4108E3FE1383}">
   <ds:schemaRefs>
-    <ds:schemaRef ds:uri="http://schemas.microsoft.com/sharepoint/v3/contenttype/forms"/>
+    <ds:schemaRef ds:uri="http://purl.org/dc/dcmitype/"/>
+    <ds:schemaRef ds:uri="http://schemas.openxmlformats.org/package/2006/metadata/core-properties"/>
+    <ds:schemaRef ds:uri="http://purl.org/dc/terms/"/>
+    <ds:schemaRef ds:uri="http://purl.org/dc/elements/1.1/"/>
+    <ds:schemaRef ds:uri="http://schemas.microsoft.com/office/2006/metadata/properties"/>
+    <ds:schemaRef ds:uri="http://schemas.microsoft.com/office/2006/documentManagement/types"/>
+    <ds:schemaRef ds:uri="http://schemas.microsoft.com/office/infopath/2007/PartnerControls"/>
+    <ds:schemaRef ds:uri="378b2ae5-9bc5-4935-9bfa-112face5173f"/>
+    <ds:schemaRef ds:uri="514a4c4d-b5b8-4628-9a2d-6541241901c3"/>
+    <ds:schemaRef ds:uri="http://www.w3.org/XML/1998/namespace"/>
   </ds:schemaRefs>
 </ds:datastoreItem>
 </file>
</xml_diff>